<commit_message>
v0.7.12.9a: Slide 2 motivation text correction
Co-Authored-By: Claude Opus 4.6 <noreply@anthropic.com>
</commit_message>
<xml_diff>
--- a/paper/publishable/task_embeddings_deck.pptx
+++ b/paper/publishable/task_embeddings_deck.pptx
@@ -2872,7 +2872,7 @@
                 <a:ea typeface="Calibri" pitchFamily="34" charset="-122"/>
                 <a:cs typeface="Calibri" pitchFamily="34" charset="-120"/>
               </a:rPr>
-              <a:t>Technology is reshaping the task content of work.</a:t>
+              <a:t>New technology is reshaping the labor market.</a:t>
             </a:r>
             <a:endParaRPr lang="en-US" sz="1400" dirty="0"/>
           </a:p>
@@ -2901,7 +2901,7 @@
                 <a:ea typeface="Calibri" pitchFamily="34" charset="-122"/>
                 <a:cs typeface="Calibri" pitchFamily="34" charset="-120"/>
               </a:rPr>
-              <a:t>Workforce policy needs a map of the task space: which occupations are nearby, and which transitions between them are feasible.</a:t>
+              <a:t>If your job is disrupted, what can you switch to?</a:t>
             </a:r>
             <a:endParaRPr lang="en-US" sz="1400" dirty="0"/>
           </a:p>
@@ -2930,7 +2930,7 @@
                 <a:ea typeface="Calibri" pitchFamily="34" charset="-122"/>
                 <a:cs typeface="Calibri" pitchFamily="34" charset="-120"/>
               </a:rPr>
-              <a:t>We propose a way to build that map — and a test for whether it works.</a:t>
+              <a:t>We propose a way to answer that question — and a test for whether it works.</a:t>
             </a:r>
             <a:endParaRPr lang="en-US" sz="1400" dirty="0"/>
           </a:p>

</xml_diff>